<commit_message>
Add project presentation slides
</commit_message>
<xml_diff>
--- a/Project_Presentation.pptx
+++ b/Project_Presentation.pptx
@@ -846,7 +846,7 @@
           <a:p>
             <a:fld id="{5BCAD085-E8A6-8845-BD4E-CB4CCA059FC4}" type="datetimeFigureOut">
               <a:rPr lang="en-US" smtClean="0"/>
-              <a:t>4/18/2026</a:t>
+              <a:t>4/18/26</a:t>
             </a:fld>
             <a:endParaRPr lang="en-US"/>
           </a:p>
@@ -1014,7 +1014,7 @@
           <a:p>
             <a:fld id="{5BCAD085-E8A6-8845-BD4E-CB4CCA059FC4}" type="datetimeFigureOut">
               <a:rPr lang="en-US" smtClean="0"/>
-              <a:t>4/18/2026</a:t>
+              <a:t>4/18/26</a:t>
             </a:fld>
             <a:endParaRPr lang="en-US"/>
           </a:p>
@@ -1192,7 +1192,7 @@
           <a:p>
             <a:fld id="{5BCAD085-E8A6-8845-BD4E-CB4CCA059FC4}" type="datetimeFigureOut">
               <a:rPr lang="en-US" smtClean="0"/>
-              <a:t>4/18/2026</a:t>
+              <a:t>4/18/26</a:t>
             </a:fld>
             <a:endParaRPr lang="en-US"/>
           </a:p>
@@ -1360,7 +1360,7 @@
           <a:p>
             <a:fld id="{5BCAD085-E8A6-8845-BD4E-CB4CCA059FC4}" type="datetimeFigureOut">
               <a:rPr lang="en-US" smtClean="0"/>
-              <a:t>4/18/2026</a:t>
+              <a:t>4/18/26</a:t>
             </a:fld>
             <a:endParaRPr lang="en-US"/>
           </a:p>
@@ -1605,7 +1605,7 @@
           <a:p>
             <a:fld id="{5BCAD085-E8A6-8845-BD4E-CB4CCA059FC4}" type="datetimeFigureOut">
               <a:rPr lang="en-US" smtClean="0"/>
-              <a:t>4/18/2026</a:t>
+              <a:t>4/18/26</a:t>
             </a:fld>
             <a:endParaRPr lang="en-US"/>
           </a:p>
@@ -1890,7 +1890,7 @@
           <a:p>
             <a:fld id="{5BCAD085-E8A6-8845-BD4E-CB4CCA059FC4}" type="datetimeFigureOut">
               <a:rPr lang="en-US" smtClean="0"/>
-              <a:t>4/18/2026</a:t>
+              <a:t>4/18/26</a:t>
             </a:fld>
             <a:endParaRPr lang="en-US"/>
           </a:p>
@@ -2309,7 +2309,7 @@
           <a:p>
             <a:fld id="{5BCAD085-E8A6-8845-BD4E-CB4CCA059FC4}" type="datetimeFigureOut">
               <a:rPr lang="en-US" smtClean="0"/>
-              <a:t>4/18/2026</a:t>
+              <a:t>4/18/26</a:t>
             </a:fld>
             <a:endParaRPr lang="en-US"/>
           </a:p>
@@ -2426,7 +2426,7 @@
           <a:p>
             <a:fld id="{5BCAD085-E8A6-8845-BD4E-CB4CCA059FC4}" type="datetimeFigureOut">
               <a:rPr lang="en-US" smtClean="0"/>
-              <a:t>4/18/2026</a:t>
+              <a:t>4/18/26</a:t>
             </a:fld>
             <a:endParaRPr lang="en-US"/>
           </a:p>
@@ -2521,7 +2521,7 @@
           <a:p>
             <a:fld id="{5BCAD085-E8A6-8845-BD4E-CB4CCA059FC4}" type="datetimeFigureOut">
               <a:rPr lang="en-US" smtClean="0"/>
-              <a:t>4/18/2026</a:t>
+              <a:t>4/18/26</a:t>
             </a:fld>
             <a:endParaRPr lang="en-US"/>
           </a:p>
@@ -2796,7 +2796,7 @@
           <a:p>
             <a:fld id="{5BCAD085-E8A6-8845-BD4E-CB4CCA059FC4}" type="datetimeFigureOut">
               <a:rPr lang="en-US" smtClean="0"/>
-              <a:t>4/18/2026</a:t>
+              <a:t>4/18/26</a:t>
             </a:fld>
             <a:endParaRPr lang="en-US"/>
           </a:p>
@@ -3048,7 +3048,7 @@
           <a:p>
             <a:fld id="{5BCAD085-E8A6-8845-BD4E-CB4CCA059FC4}" type="datetimeFigureOut">
               <a:rPr lang="en-US" smtClean="0"/>
-              <a:t>4/18/2026</a:t>
+              <a:t>4/18/26</a:t>
             </a:fld>
             <a:endParaRPr lang="en-US"/>
           </a:p>
@@ -3259,7 +3259,7 @@
           <a:p>
             <a:fld id="{5BCAD085-E8A6-8845-BD4E-CB4CCA059FC4}" type="datetimeFigureOut">
               <a:rPr lang="en-US" smtClean="0"/>
-              <a:t>4/18/2026</a:t>
+              <a:t>4/18/26</a:t>
             </a:fld>
             <a:endParaRPr lang="en-US"/>
           </a:p>
@@ -6139,30 +6139,6 @@
           <a:chExt cx="0" cy="0"/>
         </a:xfrm>
       </p:grpSpPr>
-      <p:pic>
-        <p:nvPicPr>
-          <p:cNvPr id="2" name="Picture 1" descr="iitj_logo_official.png"/>
-          <p:cNvPicPr>
-            <a:picLocks noChangeAspect="1"/>
-          </p:cNvPicPr>
-          <p:nvPr/>
-        </p:nvPicPr>
-        <p:blipFill>
-          <a:blip r:embed="rId2"/>
-          <a:stretch>
-            <a:fillRect/>
-          </a:stretch>
-        </p:blipFill>
-        <p:spPr>
-          <a:xfrm>
-            <a:off x="5212080" y="548640"/>
-            <a:ext cx="1645920" cy="1884992"/>
-          </a:xfrm>
-          <a:prstGeom prst="rect">
-            <a:avLst/>
-          </a:prstGeom>
-        </p:spPr>
-      </p:pic>
       <p:sp>
         <p:nvSpPr>
           <p:cNvPr id="3" name="TextBox 2"/>
@@ -13670,7 +13646,7 @@
         </p:nvSpPr>
         <p:spPr>
           <a:xfrm>
-            <a:off x="548640" y="3931920"/>
+            <a:off x="1898975" y="3703320"/>
             <a:ext cx="3474720" cy="1828800"/>
           </a:xfrm>
           <a:prstGeom prst="roundRect">
@@ -13716,7 +13692,7 @@
         </p:nvSpPr>
         <p:spPr>
           <a:xfrm>
-            <a:off x="731520" y="4069080"/>
+            <a:off x="2081855" y="4039840"/>
             <a:ext cx="3108960" cy="320040"/>
           </a:xfrm>
           <a:prstGeom prst="rect">
@@ -13744,6 +13720,7 @@
               </a:defRPr>
             </a:pPr>
             <a:r>
+              <a:rPr dirty="0"/>
               <a:t>View Results</a:t>
             </a:r>
           </a:p>
@@ -13757,7 +13734,7 @@
         </p:nvSpPr>
         <p:spPr>
           <a:xfrm>
-            <a:off x="731520" y="4480559"/>
+            <a:off x="1996795" y="4458231"/>
             <a:ext cx="3108960" cy="492058"/>
           </a:xfrm>
           <a:prstGeom prst="rect">
@@ -13808,7 +13785,7 @@
         </p:nvSpPr>
         <p:spPr>
           <a:xfrm>
-            <a:off x="4389120" y="3931920"/>
+            <a:off x="6431282" y="3783898"/>
             <a:ext cx="3474720" cy="1828800"/>
           </a:xfrm>
           <a:prstGeom prst="roundRect">
@@ -13854,7 +13831,7 @@
         </p:nvSpPr>
         <p:spPr>
           <a:xfrm>
-            <a:off x="4572000" y="4069080"/>
+            <a:off x="6614162" y="4078118"/>
             <a:ext cx="3108960" cy="320040"/>
           </a:xfrm>
           <a:prstGeom prst="rect">
@@ -13882,6 +13859,7 @@
               </a:defRPr>
             </a:pPr>
             <a:r>
+              <a:rPr dirty="0"/>
               <a:t>About</a:t>
             </a:r>
           </a:p>
@@ -13895,7 +13873,7 @@
         </p:nvSpPr>
         <p:spPr>
           <a:xfrm>
-            <a:off x="4572000" y="4480559"/>
+            <a:off x="6528390" y="4493850"/>
             <a:ext cx="3108960" cy="492058"/>
           </a:xfrm>
           <a:prstGeom prst="rect">
@@ -13975,47 +13953,6 @@
             </a:pPr>
             <a:r>
               <a:t>Run:  streamlit run app.py     |     Opens at http://localhost:8501     |     Upload limit: 1 GB     |     Pipeline timeout: 1 hour</a:t>
-            </a:r>
-          </a:p>
-        </p:txBody>
-      </p:sp>
-      <p:sp>
-        <p:nvSpPr>
-          <p:cNvPr id="20" name="TextBox 19"/>
-          <p:cNvSpPr txBox="1"/>
-          <p:nvPr/>
-        </p:nvSpPr>
-        <p:spPr>
-          <a:xfrm>
-            <a:off x="8046720" y="4114800"/>
-            <a:ext cx="3657600" cy="1371600"/>
-          </a:xfrm>
-          <a:prstGeom prst="rect">
-            <a:avLst/>
-          </a:prstGeom>
-          <a:noFill/>
-        </p:spPr>
-        <p:txBody>
-          <a:bodyPr wrap="square">
-            <a:spAutoFit/>
-          </a:bodyPr>
-          <a:lstStyle/>
-          <a:p>
-            <a:pPr algn="ctr">
-              <a:lnSpc>
-                <a:spcPts val="1820"/>
-              </a:lnSpc>
-              <a:spcAft>
-                <a:spcPts val="400"/>
-              </a:spcAft>
-              <a:defRPr sz="1400" b="0">
-                <a:solidFill>
-                  <a:srgbClr val="585858"/>
-                </a:solidFill>
-              </a:defRPr>
-            </a:pPr>
-            <a:r>
-              <a:t>[Insert app screenshot here]</a:t>
             </a:r>
           </a:p>
         </p:txBody>

</xml_diff>